<commit_message>
updated the ppt and report
</commit_message>
<xml_diff>
--- a/Project Presentation of CO-OP Project at Industry (Module-2) (22CS421).pptx
+++ b/Project Presentation of CO-OP Project at Industry (Module-2) (22CS421).pptx
@@ -195,7 +195,7 @@
           <a:p>
             <a:fld id="{1D8BD707-D9CF-40AE-B4C6-C98DA3205C09}" type="datetimeFigureOut">
               <a:rPr lang="en-US"/>
-              <a:t>5/17/2026</a:t>
+              <a:t>5/18/2026</a:t>
             </a:fld>
             <a:endParaRPr lang="en-US"/>
           </a:p>
@@ -378,7 +378,7 @@
           <a:p>
             <a:fld id="{1D8BD707-D9CF-40AE-B4C6-C98DA3205C09}" type="datetimeFigureOut">
               <a:rPr lang="en-US"/>
-              <a:t>5/17/2026</a:t>
+              <a:t>5/18/2026</a:t>
             </a:fld>
             <a:endParaRPr lang="en-US"/>
           </a:p>
@@ -598,7 +598,7 @@
           <a:p>
             <a:fld id="{1D8BD707-D9CF-40AE-B4C6-C98DA3205C09}" type="datetimeFigureOut">
               <a:rPr lang="en-US"/>
-              <a:t>5/17/2026</a:t>
+              <a:t>5/18/2026</a:t>
             </a:fld>
             <a:endParaRPr lang="en-US"/>
           </a:p>
@@ -1092,7 +1092,7 @@
           <a:p>
             <a:fld id="{1D8BD707-D9CF-40AE-B4C6-C98DA3205C09}" type="datetimeFigureOut">
               <a:rPr lang="en-US"/>
-              <a:t>5/17/2026</a:t>
+              <a:t>5/18/2026</a:t>
             </a:fld>
             <a:endParaRPr lang="en-US"/>
           </a:p>
@@ -1217,7 +1217,7 @@
           <a:p>
             <a:fld id="{1D8BD707-D9CF-40AE-B4C6-C98DA3205C09}" type="datetimeFigureOut">
               <a:rPr lang="en-US"/>
-              <a:t>5/17/2026</a:t>
+              <a:t>5/18/2026</a:t>
             </a:fld>
             <a:endParaRPr lang="en-US"/>
           </a:p>
@@ -1758,7 +1758,7 @@
           <a:p>
             <a:fld id="{1D8BD707-D9CF-40AE-B4C6-C98DA3205C09}" type="datetimeFigureOut">
               <a:rPr lang="en-US"/>
-              <a:t>5/17/2026</a:t>
+              <a:t>5/18/2026</a:t>
             </a:fld>
             <a:endParaRPr lang="en-US"/>
           </a:p>
@@ -2487,7 +2487,14 @@
                 <a:latin typeface="Times New Roman" panose="02020603050405020304" pitchFamily="18" charset="0"/>
                 <a:cs typeface="Times New Roman" panose="02020603050405020304" pitchFamily="18" charset="0"/>
               </a:rPr>
-              <a:t>Ms. </a:t>
+              <a:t>Dr</a:t>
+            </a:r>
+            <a:r>
+              <a:rPr lang="en-US" sz="2100" spc="-25" dirty="0" smtClean="0">
+                <a:latin typeface="Times New Roman" panose="02020603050405020304" pitchFamily="18" charset="0"/>
+                <a:cs typeface="Times New Roman" panose="02020603050405020304" pitchFamily="18" charset="0"/>
+              </a:rPr>
+              <a:t>. </a:t>
             </a:r>
             <a:r>
               <a:rPr sz="2100" dirty="0" smtClean="0">
@@ -5647,17 +5654,7 @@
                 <a:latin typeface="Times New Roman"/>
                 <a:cs typeface="Times New Roman"/>
               </a:rPr>
-              <a:t>evaluations</a:t>
-            </a:r>
-            <a:r>
-              <a:rPr lang="en-US" spc="-10" dirty="0" smtClean="0">
-                <a:solidFill>
-                  <a:schemeClr val="tx1"/>
-                </a:solidFill>
-                <a:latin typeface="Times New Roman"/>
-                <a:cs typeface="Times New Roman"/>
-              </a:rPr>
-              <a:t>.</a:t>
+              <a:t>evaluations.</a:t>
             </a:r>
           </a:p>
           <a:p>

</xml_diff>